<commit_message>
Enhance Linux vs Windows presentation with source images and motion
</commit_message>
<xml_diff>
--- a/Linux_vs_Windows_Professional.pptx
+++ b/Linux_vs_Windows_Professional.pptx
@@ -5602,11 +5602,118 @@
           </a:p>
         </p:txBody>
       </p:sp>
+      <p:pic>
+        <p:nvPicPr>
+          <p:cNvPr id="32" name="Picture 31" descr="Win 11.png"/>
+          <p:cNvPicPr>
+            <a:picLocks noChangeAspect="1"/>
+          </p:cNvPicPr>
+          <p:nvPr/>
+        </p:nvPicPr>
+        <p:blipFill>
+          <a:blip r:embed="rId3"/>
+          <a:srcRect l="29830" r="29830"/>
+          <a:stretch>
+            <a:fillRect/>
+          </a:stretch>
+        </p:blipFill>
+        <p:spPr>
+          <a:xfrm>
+            <a:off x="685800" y="2880360"/>
+            <a:ext cx="1508760" cy="1508760"/>
+          </a:xfrm>
+          <a:prstGeom prst="rect">
+            <a:avLst/>
+          </a:prstGeom>
+        </p:spPr>
+      </p:pic>
+      <p:pic>
+        <p:nvPicPr>
+          <p:cNvPr id="33" name="Picture 32" descr="Linux.jpg"/>
+          <p:cNvPicPr>
+            <a:picLocks noChangeAspect="1"/>
+          </p:cNvPicPr>
+          <p:nvPr/>
+        </p:nvPicPr>
+        <p:blipFill>
+          <a:blip r:embed="rId4"/>
+          <a:srcRect l="15115" r="15115"/>
+          <a:stretch>
+            <a:fillRect/>
+          </a:stretch>
+        </p:blipFill>
+        <p:spPr>
+          <a:xfrm>
+            <a:off x="9281160" y="2880360"/>
+            <a:ext cx="1874519" cy="1508760"/>
+          </a:xfrm>
+          <a:prstGeom prst="rect">
+            <a:avLst/>
+          </a:prstGeom>
+        </p:spPr>
+      </p:pic>
     </p:spTree>
   </p:cSld>
   <p:transition spd="med">
     <p:fade/>
   </p:transition>
+  <p:timing xmlns:p="http://schemas.openxmlformats.org/presentationml/2006/main">
+    <p:tnLst>
+      <p:par>
+        <p:cTn id="1" dur="indefinite" nodeType="tmRoot">
+          <p:childTnLst>
+            <p:seq concurrent="1" nextAc="seek">
+              <p:cTn id="2" dur="indefinite" nodeType="mainSeq">
+                <p:childTnLst>
+                  <p:par>
+                    <p:cTn id="3" fill="hold">
+                      <p:stCondLst>
+                        <p:cond delay="0"/>
+                      </p:stCondLst>
+                      <p:childTnLst>
+                        <p:par>
+                          <p:cTn id="4" fill="hold">
+                            <p:childTnLst>
+                              <p:set>
+                                <p:cBhvr>
+                                  <p:cTn id="5" dur="1" fill="hold">
+                                    <p:stCondLst>
+                                      <p:cond delay="0"/>
+                                    </p:stCondLst>
+                                  </p:cTn>
+                                  <p:tgtEl>
+                                    <p:spTgt spid="32"/>
+                                  </p:tgtEl>
+                                  <p:attrNameLst>
+                                    <p:attrName>style.visibility</p:attrName>
+                                  </p:attrNameLst>
+                                </p:cBhvr>
+                                <p:to>
+                                  <p:strVal val="visible"/>
+                                </p:to>
+                              </p:set>
+                              <p:animEffect transition="in" filter="fade">
+                                <p:cBhvr>
+                                  <p:cTn id="6" dur="900"/>
+                                  <p:tgtEl>
+                                    <p:spTgt spid="32"/>
+                                  </p:tgtEl>
+                                </p:cBhvr>
+                              </p:animEffect>
+                            </p:childTnLst>
+                          </p:cTn>
+                        </p:par>
+                      </p:childTnLst>
+                    </p:cTn>
+                  </p:par>
+                </p:childTnLst>
+              </p:cTn>
+            </p:seq>
+          </p:childTnLst>
+        </p:cTn>
+      </p:par>
+    </p:tnLst>
+  </p:timing>
   <p:clrMapOvr>
     <a:masterClrMapping/>
   </p:clrMapOvr>
@@ -6718,11 +6825,118 @@
           </a:p>
         </p:txBody>
       </p:sp>
+      <p:pic>
+        <p:nvPicPr>
+          <p:cNvPr id="29" name="Picture 28" descr="Win 11.png"/>
+          <p:cNvPicPr>
+            <a:picLocks noChangeAspect="1"/>
+          </p:cNvPicPr>
+          <p:nvPr/>
+        </p:nvPicPr>
+        <p:blipFill>
+          <a:blip r:embed="rId3"/>
+          <a:srcRect t="20837" b="20837"/>
+          <a:stretch>
+            <a:fillRect/>
+          </a:stretch>
+        </p:blipFill>
+        <p:spPr>
+          <a:xfrm>
+            <a:off x="2880360" y="1417320"/>
+            <a:ext cx="2331720" cy="548640"/>
+          </a:xfrm>
+          <a:prstGeom prst="rect">
+            <a:avLst/>
+          </a:prstGeom>
+        </p:spPr>
+      </p:pic>
+      <p:pic>
+        <p:nvPicPr>
+          <p:cNvPr id="30" name="Picture 29" descr="Arch Linux.png"/>
+          <p:cNvPicPr>
+            <a:picLocks noChangeAspect="1"/>
+          </p:cNvPicPr>
+          <p:nvPr/>
+        </p:nvPicPr>
+        <p:blipFill>
+          <a:blip r:embed="rId4"/>
+          <a:srcRect t="38235" b="38235"/>
+          <a:stretch>
+            <a:fillRect/>
+          </a:stretch>
+        </p:blipFill>
+        <p:spPr>
+          <a:xfrm>
+            <a:off x="6537960" y="1417320"/>
+            <a:ext cx="2331720" cy="548640"/>
+          </a:xfrm>
+          <a:prstGeom prst="rect">
+            <a:avLst/>
+          </a:prstGeom>
+        </p:spPr>
+      </p:pic>
     </p:spTree>
   </p:cSld>
   <p:transition spd="med">
-    <p:fade/>
+    <p:wipe dir="l"/>
   </p:transition>
+  <p:timing xmlns:p="http://schemas.openxmlformats.org/presentationml/2006/main">
+    <p:tnLst>
+      <p:par>
+        <p:cTn id="1" dur="indefinite" nodeType="tmRoot">
+          <p:childTnLst>
+            <p:seq concurrent="1" nextAc="seek">
+              <p:cTn id="2" dur="indefinite" nodeType="mainSeq">
+                <p:childTnLst>
+                  <p:par>
+                    <p:cTn id="3" fill="hold">
+                      <p:stCondLst>
+                        <p:cond delay="0"/>
+                      </p:stCondLst>
+                      <p:childTnLst>
+                        <p:par>
+                          <p:cTn id="4" fill="hold">
+                            <p:childTnLst>
+                              <p:set>
+                                <p:cBhvr>
+                                  <p:cTn id="5" dur="1" fill="hold">
+                                    <p:stCondLst>
+                                      <p:cond delay="0"/>
+                                    </p:stCondLst>
+                                  </p:cTn>
+                                  <p:tgtEl>
+                                    <p:spTgt spid="29"/>
+                                  </p:tgtEl>
+                                  <p:attrNameLst>
+                                    <p:attrName>style.visibility</p:attrName>
+                                  </p:attrNameLst>
+                                </p:cBhvr>
+                                <p:to>
+                                  <p:strVal val="visible"/>
+                                </p:to>
+                              </p:set>
+                              <p:animEffect transition="in" filter="fade">
+                                <p:cBhvr>
+                                  <p:cTn id="6" dur="900"/>
+                                  <p:tgtEl>
+                                    <p:spTgt spid="29"/>
+                                  </p:tgtEl>
+                                </p:cBhvr>
+                              </p:animEffect>
+                            </p:childTnLst>
+                          </p:cTn>
+                        </p:par>
+                      </p:childTnLst>
+                    </p:cTn>
+                  </p:par>
+                </p:childTnLst>
+              </p:cTn>
+            </p:seq>
+          </p:childTnLst>
+        </p:cTn>
+      </p:par>
+    </p:tnLst>
+  </p:timing>
   <p:clrMapOvr>
     <a:masterClrMapping/>
   </p:clrMapOvr>
@@ -7509,11 +7723,118 @@
           </a:p>
         </p:txBody>
       </p:sp>
+      <p:pic>
+        <p:nvPicPr>
+          <p:cNvPr id="21" name="Picture 20" descr="Win 11.png"/>
+          <p:cNvPicPr>
+            <a:picLocks noChangeAspect="1"/>
+          </p:cNvPicPr>
+          <p:nvPr/>
+        </p:nvPicPr>
+        <p:blipFill>
+          <a:blip r:embed="rId3"/>
+          <a:srcRect t="17300" b="17300"/>
+          <a:stretch>
+            <a:fillRect/>
+          </a:stretch>
+        </p:blipFill>
+        <p:spPr>
+          <a:xfrm>
+            <a:off x="2926080" y="2423160"/>
+            <a:ext cx="2148840" cy="566928"/>
+          </a:xfrm>
+          <a:prstGeom prst="rect">
+            <a:avLst/>
+          </a:prstGeom>
+        </p:spPr>
+      </p:pic>
+      <p:pic>
+        <p:nvPicPr>
+          <p:cNvPr id="22" name="Picture 21" descr="linux-fedora.png"/>
+          <p:cNvPicPr>
+            <a:picLocks noChangeAspect="1"/>
+          </p:cNvPicPr>
+          <p:nvPr/>
+        </p:nvPicPr>
+        <p:blipFill>
+          <a:blip r:embed="rId4"/>
+          <a:srcRect t="36809" b="36809"/>
+          <a:stretch>
+            <a:fillRect/>
+          </a:stretch>
+        </p:blipFill>
+        <p:spPr>
+          <a:xfrm>
+            <a:off x="6629400" y="2423160"/>
+            <a:ext cx="2148840" cy="566928"/>
+          </a:xfrm>
+          <a:prstGeom prst="rect">
+            <a:avLst/>
+          </a:prstGeom>
+        </p:spPr>
+      </p:pic>
     </p:spTree>
   </p:cSld>
   <p:transition spd="med">
     <p:fade/>
   </p:transition>
+  <p:timing xmlns:p="http://schemas.openxmlformats.org/presentationml/2006/main">
+    <p:tnLst>
+      <p:par>
+        <p:cTn id="1" dur="indefinite" nodeType="tmRoot">
+          <p:childTnLst>
+            <p:seq concurrent="1" nextAc="seek">
+              <p:cTn id="2" dur="indefinite" nodeType="mainSeq">
+                <p:childTnLst>
+                  <p:par>
+                    <p:cTn id="3" fill="hold">
+                      <p:stCondLst>
+                        <p:cond delay="0"/>
+                      </p:stCondLst>
+                      <p:childTnLst>
+                        <p:par>
+                          <p:cTn id="4" fill="hold">
+                            <p:childTnLst>
+                              <p:set>
+                                <p:cBhvr>
+                                  <p:cTn id="5" dur="1" fill="hold">
+                                    <p:stCondLst>
+                                      <p:cond delay="0"/>
+                                    </p:stCondLst>
+                                  </p:cTn>
+                                  <p:tgtEl>
+                                    <p:spTgt spid="21"/>
+                                  </p:tgtEl>
+                                  <p:attrNameLst>
+                                    <p:attrName>style.visibility</p:attrName>
+                                  </p:attrNameLst>
+                                </p:cBhvr>
+                                <p:to>
+                                  <p:strVal val="visible"/>
+                                </p:to>
+                              </p:set>
+                              <p:animEffect transition="in" filter="fade">
+                                <p:cBhvr>
+                                  <p:cTn id="6" dur="900"/>
+                                  <p:tgtEl>
+                                    <p:spTgt spid="21"/>
+                                  </p:tgtEl>
+                                </p:cBhvr>
+                              </p:animEffect>
+                            </p:childTnLst>
+                          </p:cTn>
+                        </p:par>
+                      </p:childTnLst>
+                    </p:cTn>
+                  </p:par>
+                </p:childTnLst>
+              </p:cTn>
+            </p:seq>
+          </p:childTnLst>
+        </p:cTn>
+      </p:par>
+    </p:tnLst>
+  </p:timing>
   <p:clrMapOvr>
     <a:masterClrMapping/>
   </p:clrMapOvr>
@@ -8633,11 +8954,118 @@
           </a:p>
         </p:txBody>
       </p:sp>
+      <p:pic>
+        <p:nvPicPr>
+          <p:cNvPr id="29" name="Picture 28" descr="Win 11.png"/>
+          <p:cNvPicPr>
+            <a:picLocks noChangeAspect="1"/>
+          </p:cNvPicPr>
+          <p:nvPr/>
+        </p:nvPicPr>
+        <p:blipFill>
+          <a:blip r:embed="rId3"/>
+          <a:srcRect l="29830" r="29830"/>
+          <a:stretch>
+            <a:fillRect/>
+          </a:stretch>
+        </p:blipFill>
+        <p:spPr>
+          <a:xfrm>
+            <a:off x="685800" y="1874519"/>
+            <a:ext cx="2423160" cy="2423160"/>
+          </a:xfrm>
+          <a:prstGeom prst="rect">
+            <a:avLst/>
+          </a:prstGeom>
+        </p:spPr>
+      </p:pic>
+      <p:pic>
+        <p:nvPicPr>
+          <p:cNvPr id="30" name="Picture 29" descr="Linux.jpg"/>
+          <p:cNvPicPr>
+            <a:picLocks noChangeAspect="1"/>
+          </p:cNvPicPr>
+          <p:nvPr/>
+        </p:nvPicPr>
+        <p:blipFill>
+          <a:blip r:embed="rId4"/>
+          <a:srcRect l="10266" r="10266"/>
+          <a:stretch>
+            <a:fillRect/>
+          </a:stretch>
+        </p:blipFill>
+        <p:spPr>
+          <a:xfrm>
+            <a:off x="3429000" y="1874519"/>
+            <a:ext cx="3429000" cy="2423160"/>
+          </a:xfrm>
+          <a:prstGeom prst="rect">
+            <a:avLst/>
+          </a:prstGeom>
+        </p:spPr>
+      </p:pic>
     </p:spTree>
   </p:cSld>
   <p:transition spd="med">
-    <p:fade/>
+    <p:push dir="r"/>
   </p:transition>
+  <p:timing xmlns:p="http://schemas.openxmlformats.org/presentationml/2006/main">
+    <p:tnLst>
+      <p:par>
+        <p:cTn id="1" dur="indefinite" nodeType="tmRoot">
+          <p:childTnLst>
+            <p:seq concurrent="1" nextAc="seek">
+              <p:cTn id="2" dur="indefinite" nodeType="mainSeq">
+                <p:childTnLst>
+                  <p:par>
+                    <p:cTn id="3" fill="hold">
+                      <p:stCondLst>
+                        <p:cond delay="0"/>
+                      </p:stCondLst>
+                      <p:childTnLst>
+                        <p:par>
+                          <p:cTn id="4" fill="hold">
+                            <p:childTnLst>
+                              <p:set>
+                                <p:cBhvr>
+                                  <p:cTn id="5" dur="1" fill="hold">
+                                    <p:stCondLst>
+                                      <p:cond delay="0"/>
+                                    </p:stCondLst>
+                                  </p:cTn>
+                                  <p:tgtEl>
+                                    <p:spTgt spid="29"/>
+                                  </p:tgtEl>
+                                  <p:attrNameLst>
+                                    <p:attrName>style.visibility</p:attrName>
+                                  </p:attrNameLst>
+                                </p:cBhvr>
+                                <p:to>
+                                  <p:strVal val="visible"/>
+                                </p:to>
+                              </p:set>
+                              <p:animEffect transition="in" filter="fade">
+                                <p:cBhvr>
+                                  <p:cTn id="6" dur="900"/>
+                                  <p:tgtEl>
+                                    <p:spTgt spid="29"/>
+                                  </p:tgtEl>
+                                </p:cBhvr>
+                              </p:animEffect>
+                            </p:childTnLst>
+                          </p:cTn>
+                        </p:par>
+                      </p:childTnLst>
+                    </p:cTn>
+                  </p:par>
+                </p:childTnLst>
+              </p:cTn>
+            </p:seq>
+          </p:childTnLst>
+        </p:cTn>
+      </p:par>
+    </p:tnLst>
+  </p:timing>
   <p:clrMapOvr>
     <a:masterClrMapping/>
   </p:clrMapOvr>
@@ -10360,11 +10788,411 @@
           </a:p>
         </p:txBody>
       </p:sp>
+      <p:pic>
+        <p:nvPicPr>
+          <p:cNvPr id="45" name="Picture 44" descr="Linux.jpg"/>
+          <p:cNvPicPr>
+            <a:picLocks noChangeAspect="1"/>
+          </p:cNvPicPr>
+          <p:nvPr/>
+        </p:nvPicPr>
+        <p:blipFill>
+          <a:blip r:embed="rId3"/>
+          <a:srcRect l="21922" r="21922"/>
+          <a:stretch>
+            <a:fillRect/>
+          </a:stretch>
+        </p:blipFill>
+        <p:spPr>
+          <a:xfrm>
+            <a:off x="713232" y="1755648"/>
+            <a:ext cx="566928" cy="566928"/>
+          </a:xfrm>
+          <a:prstGeom prst="rect">
+            <a:avLst/>
+          </a:prstGeom>
+        </p:spPr>
+      </p:pic>
+      <p:pic>
+        <p:nvPicPr>
+          <p:cNvPr id="46" name="Picture 45" descr="Red Hat Enterprise Linux.png"/>
+          <p:cNvPicPr>
+            <a:picLocks noChangeAspect="1"/>
+          </p:cNvPicPr>
+          <p:nvPr/>
+        </p:nvPicPr>
+        <p:blipFill>
+          <a:blip r:embed="rId4"/>
+          <a:srcRect l="5714" r="5714"/>
+          <a:stretch>
+            <a:fillRect/>
+          </a:stretch>
+        </p:blipFill>
+        <p:spPr>
+          <a:xfrm>
+            <a:off x="713232" y="2761488"/>
+            <a:ext cx="566928" cy="566928"/>
+          </a:xfrm>
+          <a:prstGeom prst="rect">
+            <a:avLst/>
+          </a:prstGeom>
+        </p:spPr>
+      </p:pic>
+      <p:pic>
+        <p:nvPicPr>
+          <p:cNvPr id="47" name="Picture 46" descr="linux-fedora.png"/>
+          <p:cNvPicPr>
+            <a:picLocks noChangeAspect="1"/>
+          </p:cNvPicPr>
+          <p:nvPr/>
+        </p:nvPicPr>
+        <p:blipFill>
+          <a:blip r:embed="rId5"/>
+          <a:stretch>
+            <a:fillRect/>
+          </a:stretch>
+        </p:blipFill>
+        <p:spPr>
+          <a:xfrm>
+            <a:off x="1371600" y="2761488"/>
+            <a:ext cx="566928" cy="566928"/>
+          </a:xfrm>
+          <a:prstGeom prst="rect">
+            <a:avLst/>
+          </a:prstGeom>
+        </p:spPr>
+      </p:pic>
+      <p:pic>
+        <p:nvPicPr>
+          <p:cNvPr id="48" name="Picture 47" descr="Rocky Linux.png"/>
+          <p:cNvPicPr>
+            <a:picLocks noChangeAspect="1"/>
+          </p:cNvPicPr>
+          <p:nvPr/>
+        </p:nvPicPr>
+        <p:blipFill>
+          <a:blip r:embed="rId6"/>
+          <a:stretch>
+            <a:fillRect/>
+          </a:stretch>
+        </p:blipFill>
+        <p:spPr>
+          <a:xfrm>
+            <a:off x="2029968" y="2761488"/>
+            <a:ext cx="566928" cy="566928"/>
+          </a:xfrm>
+          <a:prstGeom prst="rect">
+            <a:avLst/>
+          </a:prstGeom>
+        </p:spPr>
+      </p:pic>
+      <p:pic>
+        <p:nvPicPr>
+          <p:cNvPr id="49" name="Picture 48" descr="AlmaLinux.png"/>
+          <p:cNvPicPr>
+            <a:picLocks noChangeAspect="1"/>
+          </p:cNvPicPr>
+          <p:nvPr/>
+        </p:nvPicPr>
+        <p:blipFill>
+          <a:blip r:embed="rId7"/>
+          <a:stretch>
+            <a:fillRect/>
+          </a:stretch>
+        </p:blipFill>
+        <p:spPr>
+          <a:xfrm>
+            <a:off x="2688336" y="2761488"/>
+            <a:ext cx="566928" cy="566928"/>
+          </a:xfrm>
+          <a:prstGeom prst="rect">
+            <a:avLst/>
+          </a:prstGeom>
+        </p:spPr>
+      </p:pic>
+      <p:pic>
+        <p:nvPicPr>
+          <p:cNvPr id="50" name="Picture 49" descr="Arch Linux.png"/>
+          <p:cNvPicPr>
+            <a:picLocks noChangeAspect="1"/>
+          </p:cNvPicPr>
+          <p:nvPr/>
+        </p:nvPicPr>
+        <p:blipFill>
+          <a:blip r:embed="rId8"/>
+          <a:stretch>
+            <a:fillRect/>
+          </a:stretch>
+        </p:blipFill>
+        <p:spPr>
+          <a:xfrm>
+            <a:off x="713232" y="3767328"/>
+            <a:ext cx="566928" cy="566928"/>
+          </a:xfrm>
+          <a:prstGeom prst="rect">
+            <a:avLst/>
+          </a:prstGeom>
+        </p:spPr>
+      </p:pic>
+      <p:pic>
+        <p:nvPicPr>
+          <p:cNvPr id="51" name="Picture 50" descr="Manjaro.png"/>
+          <p:cNvPicPr>
+            <a:picLocks noChangeAspect="1"/>
+          </p:cNvPicPr>
+          <p:nvPr/>
+        </p:nvPicPr>
+        <p:blipFill>
+          <a:blip r:embed="rId9"/>
+          <a:srcRect l="38448" r="38448"/>
+          <a:stretch>
+            <a:fillRect/>
+          </a:stretch>
+        </p:blipFill>
+        <p:spPr>
+          <a:xfrm>
+            <a:off x="1371600" y="3767328"/>
+            <a:ext cx="566928" cy="566928"/>
+          </a:xfrm>
+          <a:prstGeom prst="rect">
+            <a:avLst/>
+          </a:prstGeom>
+        </p:spPr>
+      </p:pic>
+      <p:pic>
+        <p:nvPicPr>
+          <p:cNvPr id="52" name="Picture 51" descr="Windows XP.png"/>
+          <p:cNvPicPr>
+            <a:picLocks noChangeAspect="1"/>
+          </p:cNvPicPr>
+          <p:nvPr/>
+        </p:nvPicPr>
+        <p:blipFill>
+          <a:blip r:embed="rId10"/>
+          <a:stretch>
+            <a:fillRect/>
+          </a:stretch>
+        </p:blipFill>
+        <p:spPr>
+          <a:xfrm>
+            <a:off x="6327648" y="2542032"/>
+            <a:ext cx="621792" cy="621792"/>
+          </a:xfrm>
+          <a:prstGeom prst="rect">
+            <a:avLst/>
+          </a:prstGeom>
+        </p:spPr>
+      </p:pic>
+      <p:pic>
+        <p:nvPicPr>
+          <p:cNvPr id="53" name="Picture 52" descr="Windows Vista.jpg"/>
+          <p:cNvPicPr>
+            <a:picLocks noChangeAspect="1"/>
+          </p:cNvPicPr>
+          <p:nvPr/>
+        </p:nvPicPr>
+        <p:blipFill>
+          <a:blip r:embed="rId11"/>
+          <a:srcRect l="8506" r="8506"/>
+          <a:stretch>
+            <a:fillRect/>
+          </a:stretch>
+        </p:blipFill>
+        <p:spPr>
+          <a:xfrm>
+            <a:off x="7040880" y="2542032"/>
+            <a:ext cx="621792" cy="621792"/>
+          </a:xfrm>
+          <a:prstGeom prst="rect">
+            <a:avLst/>
+          </a:prstGeom>
+        </p:spPr>
+      </p:pic>
+      <p:pic>
+        <p:nvPicPr>
+          <p:cNvPr id="54" name="Picture 53" descr="Windows 7.png"/>
+          <p:cNvPicPr>
+            <a:picLocks noChangeAspect="1"/>
+          </p:cNvPicPr>
+          <p:nvPr/>
+        </p:nvPicPr>
+        <p:blipFill>
+          <a:blip r:embed="rId12"/>
+          <a:srcRect l="18496" r="18496"/>
+          <a:stretch>
+            <a:fillRect/>
+          </a:stretch>
+        </p:blipFill>
+        <p:spPr>
+          <a:xfrm>
+            <a:off x="7754112" y="2542032"/>
+            <a:ext cx="621792" cy="621792"/>
+          </a:xfrm>
+          <a:prstGeom prst="rect">
+            <a:avLst/>
+          </a:prstGeom>
+        </p:spPr>
+      </p:pic>
+      <p:pic>
+        <p:nvPicPr>
+          <p:cNvPr id="55" name="Picture 54" descr="Windows 8.png"/>
+          <p:cNvPicPr>
+            <a:picLocks noChangeAspect="1"/>
+          </p:cNvPicPr>
+          <p:nvPr/>
+        </p:nvPicPr>
+        <p:blipFill>
+          <a:blip r:embed="rId13"/>
+          <a:stretch>
+            <a:fillRect/>
+          </a:stretch>
+        </p:blipFill>
+        <p:spPr>
+          <a:xfrm>
+            <a:off x="8467344" y="2542032"/>
+            <a:ext cx="621792" cy="621792"/>
+          </a:xfrm>
+          <a:prstGeom prst="rect">
+            <a:avLst/>
+          </a:prstGeom>
+        </p:spPr>
+      </p:pic>
+      <p:pic>
+        <p:nvPicPr>
+          <p:cNvPr id="56" name="Picture 55" descr="Windows 8.1.jpg"/>
+          <p:cNvPicPr>
+            <a:picLocks noChangeAspect="1"/>
+          </p:cNvPicPr>
+          <p:nvPr/>
+        </p:nvPicPr>
+        <p:blipFill>
+          <a:blip r:embed="rId14"/>
+          <a:srcRect l="16114" r="16114"/>
+          <a:stretch>
+            <a:fillRect/>
+          </a:stretch>
+        </p:blipFill>
+        <p:spPr>
+          <a:xfrm>
+            <a:off x="9180576" y="2542032"/>
+            <a:ext cx="621792" cy="621792"/>
+          </a:xfrm>
+          <a:prstGeom prst="rect">
+            <a:avLst/>
+          </a:prstGeom>
+        </p:spPr>
+      </p:pic>
+      <p:pic>
+        <p:nvPicPr>
+          <p:cNvPr id="57" name="Picture 56" descr="Windows 10.png"/>
+          <p:cNvPicPr>
+            <a:picLocks noChangeAspect="1"/>
+          </p:cNvPicPr>
+          <p:nvPr/>
+        </p:nvPicPr>
+        <p:blipFill>
+          <a:blip r:embed="rId15"/>
+          <a:stretch>
+            <a:fillRect/>
+          </a:stretch>
+        </p:blipFill>
+        <p:spPr>
+          <a:xfrm>
+            <a:off x="9893808" y="2542032"/>
+            <a:ext cx="621792" cy="621792"/>
+          </a:xfrm>
+          <a:prstGeom prst="rect">
+            <a:avLst/>
+          </a:prstGeom>
+        </p:spPr>
+      </p:pic>
+      <p:pic>
+        <p:nvPicPr>
+          <p:cNvPr id="58" name="Picture 57" descr="Win 11.png"/>
+          <p:cNvPicPr>
+            <a:picLocks noChangeAspect="1"/>
+          </p:cNvPicPr>
+          <p:nvPr/>
+        </p:nvPicPr>
+        <p:blipFill>
+          <a:blip r:embed="rId16"/>
+          <a:srcRect l="29830" r="29830"/>
+          <a:stretch>
+            <a:fillRect/>
+          </a:stretch>
+        </p:blipFill>
+        <p:spPr>
+          <a:xfrm>
+            <a:off x="10607040" y="2542032"/>
+            <a:ext cx="621792" cy="621792"/>
+          </a:xfrm>
+          <a:prstGeom prst="rect">
+            <a:avLst/>
+          </a:prstGeom>
+        </p:spPr>
+      </p:pic>
     </p:spTree>
   </p:cSld>
   <p:transition spd="med">
-    <p:fade/>
+    <p:wipe dir="l"/>
   </p:transition>
+  <p:timing xmlns:p="http://schemas.openxmlformats.org/presentationml/2006/main">
+    <p:tnLst>
+      <p:par>
+        <p:cTn id="1" dur="indefinite" nodeType="tmRoot">
+          <p:childTnLst>
+            <p:seq concurrent="1" nextAc="seek">
+              <p:cTn id="2" dur="indefinite" nodeType="mainSeq">
+                <p:childTnLst>
+                  <p:par>
+                    <p:cTn id="3" fill="hold">
+                      <p:stCondLst>
+                        <p:cond delay="0"/>
+                      </p:stCondLst>
+                      <p:childTnLst>
+                        <p:par>
+                          <p:cTn id="4" fill="hold">
+                            <p:childTnLst>
+                              <p:set>
+                                <p:cBhvr>
+                                  <p:cTn id="5" dur="1" fill="hold">
+                                    <p:stCondLst>
+                                      <p:cond delay="0"/>
+                                    </p:stCondLst>
+                                  </p:cTn>
+                                  <p:tgtEl>
+                                    <p:spTgt spid="45"/>
+                                  </p:tgtEl>
+                                  <p:attrNameLst>
+                                    <p:attrName>style.visibility</p:attrName>
+                                  </p:attrNameLst>
+                                </p:cBhvr>
+                                <p:to>
+                                  <p:strVal val="visible"/>
+                                </p:to>
+                              </p:set>
+                              <p:animEffect transition="in" filter="fade">
+                                <p:cBhvr>
+                                  <p:cTn id="6" dur="900"/>
+                                  <p:tgtEl>
+                                    <p:spTgt spid="45"/>
+                                  </p:tgtEl>
+                                </p:cBhvr>
+                              </p:animEffect>
+                            </p:childTnLst>
+                          </p:cTn>
+                        </p:par>
+                      </p:childTnLst>
+                    </p:cTn>
+                  </p:par>
+                </p:childTnLst>
+              </p:cTn>
+            </p:seq>
+          </p:childTnLst>
+        </p:cTn>
+      </p:par>
+    </p:tnLst>
+  </p:timing>
   <p:clrMapOvr>
     <a:masterClrMapping/>
   </p:clrMapOvr>
@@ -11294,11 +12122,118 @@
           </a:p>
         </p:txBody>
       </p:sp>
+      <p:pic>
+        <p:nvPicPr>
+          <p:cNvPr id="25" name="Picture 24" descr="Win 11.png"/>
+          <p:cNvPicPr>
+            <a:picLocks noChangeAspect="1"/>
+          </p:cNvPicPr>
+          <p:nvPr/>
+        </p:nvPicPr>
+        <p:blipFill>
+          <a:blip r:embed="rId3"/>
+          <a:srcRect l="11493" r="11493"/>
+          <a:stretch>
+            <a:fillRect/>
+          </a:stretch>
+        </p:blipFill>
+        <p:spPr>
+          <a:xfrm>
+            <a:off x="777240" y="4590288"/>
+            <a:ext cx="960120" cy="502920"/>
+          </a:xfrm>
+          <a:prstGeom prst="rect">
+            <a:avLst/>
+          </a:prstGeom>
+        </p:spPr>
+      </p:pic>
+      <p:pic>
+        <p:nvPicPr>
+          <p:cNvPr id="26" name="Picture 25" descr="Manjaro.png"/>
+          <p:cNvPicPr>
+            <a:picLocks noChangeAspect="1"/>
+          </p:cNvPicPr>
+          <p:nvPr/>
+        </p:nvPicPr>
+        <p:blipFill>
+          <a:blip r:embed="rId4"/>
+          <a:srcRect l="27946" r="27946"/>
+          <a:stretch>
+            <a:fillRect/>
+          </a:stretch>
+        </p:blipFill>
+        <p:spPr>
+          <a:xfrm>
+            <a:off x="10012680" y="4590288"/>
+            <a:ext cx="960120" cy="502920"/>
+          </a:xfrm>
+          <a:prstGeom prst="rect">
+            <a:avLst/>
+          </a:prstGeom>
+        </p:spPr>
+      </p:pic>
     </p:spTree>
   </p:cSld>
   <p:transition spd="med">
     <p:fade/>
   </p:transition>
+  <p:timing xmlns:p="http://schemas.openxmlformats.org/presentationml/2006/main">
+    <p:tnLst>
+      <p:par>
+        <p:cTn id="1" dur="indefinite" nodeType="tmRoot">
+          <p:childTnLst>
+            <p:seq concurrent="1" nextAc="seek">
+              <p:cTn id="2" dur="indefinite" nodeType="mainSeq">
+                <p:childTnLst>
+                  <p:par>
+                    <p:cTn id="3" fill="hold">
+                      <p:stCondLst>
+                        <p:cond delay="0"/>
+                      </p:stCondLst>
+                      <p:childTnLst>
+                        <p:par>
+                          <p:cTn id="4" fill="hold">
+                            <p:childTnLst>
+                              <p:set>
+                                <p:cBhvr>
+                                  <p:cTn id="5" dur="1" fill="hold">
+                                    <p:stCondLst>
+                                      <p:cond delay="0"/>
+                                    </p:stCondLst>
+                                  </p:cTn>
+                                  <p:tgtEl>
+                                    <p:spTgt spid="25"/>
+                                  </p:tgtEl>
+                                  <p:attrNameLst>
+                                    <p:attrName>style.visibility</p:attrName>
+                                  </p:attrNameLst>
+                                </p:cBhvr>
+                                <p:to>
+                                  <p:strVal val="visible"/>
+                                </p:to>
+                              </p:set>
+                              <p:animEffect transition="in" filter="fade">
+                                <p:cBhvr>
+                                  <p:cTn id="6" dur="900"/>
+                                  <p:tgtEl>
+                                    <p:spTgt spid="25"/>
+                                  </p:tgtEl>
+                                </p:cBhvr>
+                              </p:animEffect>
+                            </p:childTnLst>
+                          </p:cTn>
+                        </p:par>
+                      </p:childTnLst>
+                    </p:cTn>
+                  </p:par>
+                </p:childTnLst>
+              </p:cTn>
+            </p:seq>
+          </p:childTnLst>
+        </p:cTn>
+      </p:par>
+    </p:tnLst>
+  </p:timing>
   <p:clrMapOvr>
     <a:masterClrMapping/>
   </p:clrMapOvr>
@@ -12068,11 +13003,118 @@
           </a:p>
         </p:txBody>
       </p:sp>
+      <p:pic>
+        <p:nvPicPr>
+          <p:cNvPr id="21" name="Picture 20" descr="Windows 10.png"/>
+          <p:cNvPicPr>
+            <a:picLocks noChangeAspect="1"/>
+          </p:cNvPicPr>
+          <p:nvPr/>
+        </p:nvPicPr>
+        <p:blipFill>
+          <a:blip r:embed="rId3"/>
+          <a:srcRect t="29630" b="29630"/>
+          <a:stretch>
+            <a:fillRect/>
+          </a:stretch>
+        </p:blipFill>
+        <p:spPr>
+          <a:xfrm>
+            <a:off x="960120" y="4663440"/>
+            <a:ext cx="1234440" cy="502920"/>
+          </a:xfrm>
+          <a:prstGeom prst="rect">
+            <a:avLst/>
+          </a:prstGeom>
+        </p:spPr>
+      </p:pic>
+      <p:pic>
+        <p:nvPicPr>
+          <p:cNvPr id="22" name="Picture 21" descr="AlmaLinux.png"/>
+          <p:cNvPicPr>
+            <a:picLocks noChangeAspect="1"/>
+          </p:cNvPicPr>
+          <p:nvPr/>
+        </p:nvPicPr>
+        <p:blipFill>
+          <a:blip r:embed="rId4"/>
+          <a:srcRect t="29630" b="29630"/>
+          <a:stretch>
+            <a:fillRect/>
+          </a:stretch>
+        </p:blipFill>
+        <p:spPr>
+          <a:xfrm>
+            <a:off x="4754880" y="4663440"/>
+            <a:ext cx="1234440" cy="502920"/>
+          </a:xfrm>
+          <a:prstGeom prst="rect">
+            <a:avLst/>
+          </a:prstGeom>
+        </p:spPr>
+      </p:pic>
     </p:spTree>
   </p:cSld>
   <p:transition spd="med">
-    <p:fade/>
+    <p:push dir="r"/>
   </p:transition>
+  <p:timing xmlns:p="http://schemas.openxmlformats.org/presentationml/2006/main">
+    <p:tnLst>
+      <p:par>
+        <p:cTn id="1" dur="indefinite" nodeType="tmRoot">
+          <p:childTnLst>
+            <p:seq concurrent="1" nextAc="seek">
+              <p:cTn id="2" dur="indefinite" nodeType="mainSeq">
+                <p:childTnLst>
+                  <p:par>
+                    <p:cTn id="3" fill="hold">
+                      <p:stCondLst>
+                        <p:cond delay="0"/>
+                      </p:stCondLst>
+                      <p:childTnLst>
+                        <p:par>
+                          <p:cTn id="4" fill="hold">
+                            <p:childTnLst>
+                              <p:set>
+                                <p:cBhvr>
+                                  <p:cTn id="5" dur="1" fill="hold">
+                                    <p:stCondLst>
+                                      <p:cond delay="0"/>
+                                    </p:stCondLst>
+                                  </p:cTn>
+                                  <p:tgtEl>
+                                    <p:spTgt spid="21"/>
+                                  </p:tgtEl>
+                                  <p:attrNameLst>
+                                    <p:attrName>style.visibility</p:attrName>
+                                  </p:attrNameLst>
+                                </p:cBhvr>
+                                <p:to>
+                                  <p:strVal val="visible"/>
+                                </p:to>
+                              </p:set>
+                              <p:animEffect transition="in" filter="fade">
+                                <p:cBhvr>
+                                  <p:cTn id="6" dur="900"/>
+                                  <p:tgtEl>
+                                    <p:spTgt spid="21"/>
+                                  </p:tgtEl>
+                                </p:cBhvr>
+                              </p:animEffect>
+                            </p:childTnLst>
+                          </p:cTn>
+                        </p:par>
+                      </p:childTnLst>
+                    </p:cTn>
+                  </p:par>
+                </p:childTnLst>
+              </p:cTn>
+            </p:seq>
+          </p:childTnLst>
+        </p:cTn>
+      </p:par>
+    </p:tnLst>
+  </p:timing>
   <p:clrMapOvr>
     <a:masterClrMapping/>
   </p:clrMapOvr>
@@ -12888,11 +13930,118 @@
           </a:p>
         </p:txBody>
       </p:sp>
+      <p:pic>
+        <p:nvPicPr>
+          <p:cNvPr id="22" name="Picture 21" descr="Red Hat Enterprise Linux.png"/>
+          <p:cNvPicPr>
+            <a:picLocks noChangeAspect="1"/>
+          </p:cNvPicPr>
+          <p:nvPr/>
+        </p:nvPicPr>
+        <p:blipFill>
+          <a:blip r:embed="rId3"/>
+          <a:srcRect t="28288" b="28288"/>
+          <a:stretch>
+            <a:fillRect/>
+          </a:stretch>
+        </p:blipFill>
+        <p:spPr>
+          <a:xfrm>
+            <a:off x="685800" y="1737360"/>
+            <a:ext cx="1783080" cy="685800"/>
+          </a:xfrm>
+          <a:prstGeom prst="rect">
+            <a:avLst/>
+          </a:prstGeom>
+        </p:spPr>
+      </p:pic>
+      <p:pic>
+        <p:nvPicPr>
+          <p:cNvPr id="23" name="Picture 22" descr="Win 11.png"/>
+          <p:cNvPicPr>
+            <a:picLocks noChangeAspect="1"/>
+          </p:cNvPicPr>
+          <p:nvPr/>
+        </p:nvPicPr>
+        <p:blipFill>
+          <a:blip r:embed="rId4"/>
+          <a:srcRect t="423" b="423"/>
+          <a:stretch>
+            <a:fillRect/>
+          </a:stretch>
+        </p:blipFill>
+        <p:spPr>
+          <a:xfrm>
+            <a:off x="7498079" y="4480560"/>
+            <a:ext cx="1417320" cy="566928"/>
+          </a:xfrm>
+          <a:prstGeom prst="rect">
+            <a:avLst/>
+          </a:prstGeom>
+        </p:spPr>
+      </p:pic>
     </p:spTree>
   </p:cSld>
   <p:transition spd="med">
     <p:fade/>
   </p:transition>
+  <p:timing xmlns:p="http://schemas.openxmlformats.org/presentationml/2006/main">
+    <p:tnLst>
+      <p:par>
+        <p:cTn id="1" dur="indefinite" nodeType="tmRoot">
+          <p:childTnLst>
+            <p:seq concurrent="1" nextAc="seek">
+              <p:cTn id="2" dur="indefinite" nodeType="mainSeq">
+                <p:childTnLst>
+                  <p:par>
+                    <p:cTn id="3" fill="hold">
+                      <p:stCondLst>
+                        <p:cond delay="0"/>
+                      </p:stCondLst>
+                      <p:childTnLst>
+                        <p:par>
+                          <p:cTn id="4" fill="hold">
+                            <p:childTnLst>
+                              <p:set>
+                                <p:cBhvr>
+                                  <p:cTn id="5" dur="1" fill="hold">
+                                    <p:stCondLst>
+                                      <p:cond delay="0"/>
+                                    </p:stCondLst>
+                                  </p:cTn>
+                                  <p:tgtEl>
+                                    <p:spTgt spid="22"/>
+                                  </p:tgtEl>
+                                  <p:attrNameLst>
+                                    <p:attrName>style.visibility</p:attrName>
+                                  </p:attrNameLst>
+                                </p:cBhvr>
+                                <p:to>
+                                  <p:strVal val="visible"/>
+                                </p:to>
+                              </p:set>
+                              <p:animEffect transition="in" filter="fade">
+                                <p:cBhvr>
+                                  <p:cTn id="6" dur="900"/>
+                                  <p:tgtEl>
+                                    <p:spTgt spid="22"/>
+                                  </p:tgtEl>
+                                </p:cBhvr>
+                              </p:animEffect>
+                            </p:childTnLst>
+                          </p:cTn>
+                        </p:par>
+                      </p:childTnLst>
+                    </p:cTn>
+                  </p:par>
+                </p:childTnLst>
+              </p:cTn>
+            </p:seq>
+          </p:childTnLst>
+        </p:cTn>
+      </p:par>
+    </p:tnLst>
+  </p:timing>
   <p:clrMapOvr>
     <a:masterClrMapping/>
   </p:clrMapOvr>
@@ -13666,11 +14815,118 @@
           </a:p>
         </p:txBody>
       </p:sp>
+      <p:pic>
+        <p:nvPicPr>
+          <p:cNvPr id="21" name="Picture 20" descr="Win 11.png"/>
+          <p:cNvPicPr>
+            <a:picLocks noChangeAspect="1"/>
+          </p:cNvPicPr>
+          <p:nvPr/>
+        </p:nvPicPr>
+        <p:blipFill>
+          <a:blip r:embed="rId3"/>
+          <a:srcRect t="2987" b="2987"/>
+          <a:stretch>
+            <a:fillRect/>
+          </a:stretch>
+        </p:blipFill>
+        <p:spPr>
+          <a:xfrm>
+            <a:off x="1005840" y="4645152"/>
+            <a:ext cx="1325880" cy="502920"/>
+          </a:xfrm>
+          <a:prstGeom prst="rect">
+            <a:avLst/>
+          </a:prstGeom>
+        </p:spPr>
+      </p:pic>
+      <p:pic>
+        <p:nvPicPr>
+          <p:cNvPr id="22" name="Picture 21" descr="linux-fedora.png"/>
+          <p:cNvPicPr>
+            <a:picLocks noChangeAspect="1"/>
+          </p:cNvPicPr>
+          <p:nvPr/>
+        </p:nvPicPr>
+        <p:blipFill>
+          <a:blip r:embed="rId4"/>
+          <a:srcRect t="31034" b="31034"/>
+          <a:stretch>
+            <a:fillRect/>
+          </a:stretch>
+        </p:blipFill>
+        <p:spPr>
+          <a:xfrm>
+            <a:off x="4572000" y="4645152"/>
+            <a:ext cx="1325880" cy="502920"/>
+          </a:xfrm>
+          <a:prstGeom prst="rect">
+            <a:avLst/>
+          </a:prstGeom>
+        </p:spPr>
+      </p:pic>
     </p:spTree>
   </p:cSld>
   <p:transition spd="med">
-    <p:fade/>
+    <p:wipe dir="l"/>
   </p:transition>
+  <p:timing xmlns:p="http://schemas.openxmlformats.org/presentationml/2006/main">
+    <p:tnLst>
+      <p:par>
+        <p:cTn id="1" dur="indefinite" nodeType="tmRoot">
+          <p:childTnLst>
+            <p:seq concurrent="1" nextAc="seek">
+              <p:cTn id="2" dur="indefinite" nodeType="mainSeq">
+                <p:childTnLst>
+                  <p:par>
+                    <p:cTn id="3" fill="hold">
+                      <p:stCondLst>
+                        <p:cond delay="0"/>
+                      </p:stCondLst>
+                      <p:childTnLst>
+                        <p:par>
+                          <p:cTn id="4" fill="hold">
+                            <p:childTnLst>
+                              <p:set>
+                                <p:cBhvr>
+                                  <p:cTn id="5" dur="1" fill="hold">
+                                    <p:stCondLst>
+                                      <p:cond delay="0"/>
+                                    </p:stCondLst>
+                                  </p:cTn>
+                                  <p:tgtEl>
+                                    <p:spTgt spid="21"/>
+                                  </p:tgtEl>
+                                  <p:attrNameLst>
+                                    <p:attrName>style.visibility</p:attrName>
+                                  </p:attrNameLst>
+                                </p:cBhvr>
+                                <p:to>
+                                  <p:strVal val="visible"/>
+                                </p:to>
+                              </p:set>
+                              <p:animEffect transition="in" filter="fade">
+                                <p:cBhvr>
+                                  <p:cTn id="6" dur="900"/>
+                                  <p:tgtEl>
+                                    <p:spTgt spid="21"/>
+                                  </p:tgtEl>
+                                </p:cBhvr>
+                              </p:animEffect>
+                            </p:childTnLst>
+                          </p:cTn>
+                        </p:par>
+                      </p:childTnLst>
+                    </p:cTn>
+                  </p:par>
+                </p:childTnLst>
+              </p:cTn>
+            </p:seq>
+          </p:childTnLst>
+        </p:cTn>
+      </p:par>
+    </p:tnLst>
+  </p:timing>
   <p:clrMapOvr>
     <a:masterClrMapping/>
   </p:clrMapOvr>
@@ -14811,11 +16067,117 @@
           </a:p>
         </p:txBody>
       </p:sp>
+      <p:pic>
+        <p:nvPicPr>
+          <p:cNvPr id="30" name="Picture 29" descr="Arch Linux.png"/>
+          <p:cNvPicPr>
+            <a:picLocks noChangeAspect="1"/>
+          </p:cNvPicPr>
+          <p:nvPr/>
+        </p:nvPicPr>
+        <p:blipFill>
+          <a:blip r:embed="rId3"/>
+          <a:stretch>
+            <a:fillRect/>
+          </a:stretch>
+        </p:blipFill>
+        <p:spPr>
+          <a:xfrm>
+            <a:off x="731520" y="1828800"/>
+            <a:ext cx="2423160" cy="2423160"/>
+          </a:xfrm>
+          <a:prstGeom prst="rect">
+            <a:avLst/>
+          </a:prstGeom>
+        </p:spPr>
+      </p:pic>
+      <p:pic>
+        <p:nvPicPr>
+          <p:cNvPr id="31" name="Picture 30" descr="Manjaro.png"/>
+          <p:cNvPicPr>
+            <a:picLocks noChangeAspect="1"/>
+          </p:cNvPicPr>
+          <p:nvPr/>
+        </p:nvPicPr>
+        <p:blipFill>
+          <a:blip r:embed="rId4"/>
+          <a:srcRect l="623" r="623"/>
+          <a:stretch>
+            <a:fillRect/>
+          </a:stretch>
+        </p:blipFill>
+        <p:spPr>
+          <a:xfrm>
+            <a:off x="731520" y="4160520"/>
+            <a:ext cx="2423160" cy="566928"/>
+          </a:xfrm>
+          <a:prstGeom prst="rect">
+            <a:avLst/>
+          </a:prstGeom>
+        </p:spPr>
+      </p:pic>
     </p:spTree>
   </p:cSld>
   <p:transition spd="med">
     <p:fade/>
   </p:transition>
+  <p:timing xmlns:p="http://schemas.openxmlformats.org/presentationml/2006/main">
+    <p:tnLst>
+      <p:par>
+        <p:cTn id="1" dur="indefinite" nodeType="tmRoot">
+          <p:childTnLst>
+            <p:seq concurrent="1" nextAc="seek">
+              <p:cTn id="2" dur="indefinite" nodeType="mainSeq">
+                <p:childTnLst>
+                  <p:par>
+                    <p:cTn id="3" fill="hold">
+                      <p:stCondLst>
+                        <p:cond delay="0"/>
+                      </p:stCondLst>
+                      <p:childTnLst>
+                        <p:par>
+                          <p:cTn id="4" fill="hold">
+                            <p:childTnLst>
+                              <p:set>
+                                <p:cBhvr>
+                                  <p:cTn id="5" dur="1" fill="hold">
+                                    <p:stCondLst>
+                                      <p:cond delay="0"/>
+                                    </p:stCondLst>
+                                  </p:cTn>
+                                  <p:tgtEl>
+                                    <p:spTgt spid="30"/>
+                                  </p:tgtEl>
+                                  <p:attrNameLst>
+                                    <p:attrName>style.visibility</p:attrName>
+                                  </p:attrNameLst>
+                                </p:cBhvr>
+                                <p:to>
+                                  <p:strVal val="visible"/>
+                                </p:to>
+                              </p:set>
+                              <p:animEffect transition="in" filter="fade">
+                                <p:cBhvr>
+                                  <p:cTn id="6" dur="900"/>
+                                  <p:tgtEl>
+                                    <p:spTgt spid="30"/>
+                                  </p:tgtEl>
+                                </p:cBhvr>
+                              </p:animEffect>
+                            </p:childTnLst>
+                          </p:cTn>
+                        </p:par>
+                      </p:childTnLst>
+                    </p:cTn>
+                  </p:par>
+                </p:childTnLst>
+              </p:cTn>
+            </p:seq>
+          </p:childTnLst>
+        </p:cTn>
+      </p:par>
+    </p:tnLst>
+  </p:timing>
   <p:clrMapOvr>
     <a:masterClrMapping/>
   </p:clrMapOvr>
@@ -15499,11 +16861,118 @@
           </a:p>
         </p:txBody>
       </p:sp>
+      <p:pic>
+        <p:nvPicPr>
+          <p:cNvPr id="19" name="Picture 18" descr="Linux.jpg"/>
+          <p:cNvPicPr>
+            <a:picLocks noChangeAspect="1"/>
+          </p:cNvPicPr>
+          <p:nvPr/>
+        </p:nvPicPr>
+        <p:blipFill>
+          <a:blip r:embed="rId3"/>
+          <a:srcRect l="8551" r="8551"/>
+          <a:stretch>
+            <a:fillRect/>
+          </a:stretch>
+        </p:blipFill>
+        <p:spPr>
+          <a:xfrm>
+            <a:off x="777240" y="2331720"/>
+            <a:ext cx="1417320" cy="960120"/>
+          </a:xfrm>
+          <a:prstGeom prst="rect">
+            <a:avLst/>
+          </a:prstGeom>
+        </p:spPr>
+      </p:pic>
+      <p:pic>
+        <p:nvPicPr>
+          <p:cNvPr id="20" name="Picture 19" descr="Windows XP.png"/>
+          <p:cNvPicPr>
+            <a:picLocks noChangeAspect="1"/>
+          </p:cNvPicPr>
+          <p:nvPr/>
+        </p:nvPicPr>
+        <p:blipFill>
+          <a:blip r:embed="rId4"/>
+          <a:srcRect t="16129" b="16129"/>
+          <a:stretch>
+            <a:fillRect/>
+          </a:stretch>
+        </p:blipFill>
+        <p:spPr>
+          <a:xfrm>
+            <a:off x="9646920" y="2331720"/>
+            <a:ext cx="1417320" cy="960120"/>
+          </a:xfrm>
+          <a:prstGeom prst="rect">
+            <a:avLst/>
+          </a:prstGeom>
+        </p:spPr>
+      </p:pic>
     </p:spTree>
   </p:cSld>
   <p:transition spd="med">
-    <p:fade/>
+    <p:push dir="r"/>
   </p:transition>
+  <p:timing xmlns:p="http://schemas.openxmlformats.org/presentationml/2006/main">
+    <p:tnLst>
+      <p:par>
+        <p:cTn id="1" dur="indefinite" nodeType="tmRoot">
+          <p:childTnLst>
+            <p:seq concurrent="1" nextAc="seek">
+              <p:cTn id="2" dur="indefinite" nodeType="mainSeq">
+                <p:childTnLst>
+                  <p:par>
+                    <p:cTn id="3" fill="hold">
+                      <p:stCondLst>
+                        <p:cond delay="0"/>
+                      </p:stCondLst>
+                      <p:childTnLst>
+                        <p:par>
+                          <p:cTn id="4" fill="hold">
+                            <p:childTnLst>
+                              <p:set>
+                                <p:cBhvr>
+                                  <p:cTn id="5" dur="1" fill="hold">
+                                    <p:stCondLst>
+                                      <p:cond delay="0"/>
+                                    </p:stCondLst>
+                                  </p:cTn>
+                                  <p:tgtEl>
+                                    <p:spTgt spid="19"/>
+                                  </p:tgtEl>
+                                  <p:attrNameLst>
+                                    <p:attrName>style.visibility</p:attrName>
+                                  </p:attrNameLst>
+                                </p:cBhvr>
+                                <p:to>
+                                  <p:strVal val="visible"/>
+                                </p:to>
+                              </p:set>
+                              <p:animEffect transition="in" filter="fade">
+                                <p:cBhvr>
+                                  <p:cTn id="6" dur="900"/>
+                                  <p:tgtEl>
+                                    <p:spTgt spid="19"/>
+                                  </p:tgtEl>
+                                </p:cBhvr>
+                              </p:animEffect>
+                            </p:childTnLst>
+                          </p:cTn>
+                        </p:par>
+                      </p:childTnLst>
+                    </p:cTn>
+                  </p:par>
+                </p:childTnLst>
+              </p:cTn>
+            </p:seq>
+          </p:childTnLst>
+        </p:cTn>
+      </p:par>
+    </p:tnLst>
+  </p:timing>
   <p:clrMapOvr>
     <a:masterClrMapping/>
   </p:clrMapOvr>

</xml_diff>

<commit_message>
fix: correct PowerPoint image aspect ratios
</commit_message>
<xml_diff>
--- a/Linux_vs_Windows_Professional.pptx
+++ b/Linux_vs_Windows_Professional.pptx
@@ -4811,8 +4811,8 @@
         </p:blipFill>
         <p:spPr>
           <a:xfrm>
-            <a:off x="8183879" y="868680"/>
-            <a:ext cx="3246120" cy="1417320"/>
+            <a:off x="8183879" y="922583"/>
+            <a:ext cx="3246120" cy="1309514"/>
           </a:xfrm>
           <a:prstGeom prst="rect">
             <a:avLst/>
@@ -4836,8 +4836,8 @@
         </p:blipFill>
         <p:spPr>
           <a:xfrm>
-            <a:off x="8183879" y="2542032"/>
-            <a:ext cx="3246120" cy="1828800"/>
+            <a:off x="8183879" y="2544971"/>
+            <a:ext cx="3246120" cy="1822922"/>
           </a:xfrm>
           <a:prstGeom prst="rect">
             <a:avLst/>
@@ -5192,8 +5192,8 @@
         </p:blipFill>
         <p:spPr>
           <a:xfrm>
-            <a:off x="932688" y="2057400"/>
-            <a:ext cx="4709160" cy="1097280"/>
+            <a:off x="1927259" y="2057400"/>
+            <a:ext cx="2720018" cy="1097280"/>
           </a:xfrm>
           <a:prstGeom prst="rect">
             <a:avLst/>
@@ -5379,8 +5379,8 @@
         </p:blipFill>
         <p:spPr>
           <a:xfrm>
-            <a:off x="6547104" y="2057400"/>
-            <a:ext cx="4681728" cy="1097280"/>
+            <a:off x="8339328" y="2057400"/>
+            <a:ext cx="1097280" cy="1097280"/>
           </a:xfrm>
           <a:prstGeom prst="rect">
             <a:avLst/>
@@ -5762,8 +5762,8 @@
         </p:blipFill>
         <p:spPr>
           <a:xfrm>
-            <a:off x="960120" y="1847088"/>
-            <a:ext cx="4160520" cy="1234440"/>
+            <a:off x="1510370" y="1847088"/>
+            <a:ext cx="3060020" cy="1234440"/>
           </a:xfrm>
           <a:prstGeom prst="rect">
             <a:avLst/>
@@ -5787,8 +5787,8 @@
         </p:blipFill>
         <p:spPr>
           <a:xfrm>
-            <a:off x="7059168" y="1847088"/>
-            <a:ext cx="4160520" cy="1234440"/>
+            <a:off x="8522208" y="1847088"/>
+            <a:ext cx="1234440" cy="1234440"/>
           </a:xfrm>
           <a:prstGeom prst="rect">
             <a:avLst/>
@@ -6339,8 +6339,8 @@
         </p:blipFill>
         <p:spPr>
           <a:xfrm>
-            <a:off x="960120" y="2029968"/>
-            <a:ext cx="2240280" cy="960120"/>
+            <a:off x="960120" y="2058153"/>
+            <a:ext cx="2240280" cy="903749"/>
           </a:xfrm>
           <a:prstGeom prst="rect">
             <a:avLst/>
@@ -6515,8 +6515,8 @@
         </p:blipFill>
         <p:spPr>
           <a:xfrm>
-            <a:off x="6565392" y="2029968"/>
-            <a:ext cx="2240280" cy="960120"/>
+            <a:off x="6830678" y="2029968"/>
+            <a:ext cx="1709707" cy="960119"/>
           </a:xfrm>
           <a:prstGeom prst="rect">
             <a:avLst/>
@@ -7057,8 +7057,8 @@
         </p:blipFill>
         <p:spPr>
           <a:xfrm>
-            <a:off x="2907792" y="2212848"/>
-            <a:ext cx="438912" cy="438912"/>
+            <a:off x="2907792" y="2309064"/>
+            <a:ext cx="438912" cy="246479"/>
           </a:xfrm>
           <a:prstGeom prst="rect">
             <a:avLst/>
@@ -7082,8 +7082,8 @@
         </p:blipFill>
         <p:spPr>
           <a:xfrm>
-            <a:off x="3456432" y="2212848"/>
-            <a:ext cx="438912" cy="438912"/>
+            <a:off x="3456432" y="2309064"/>
+            <a:ext cx="438912" cy="246479"/>
           </a:xfrm>
           <a:prstGeom prst="rect">
             <a:avLst/>
@@ -7267,8 +7267,8 @@
         </p:blipFill>
         <p:spPr>
           <a:xfrm>
-            <a:off x="2907792" y="3236976"/>
-            <a:ext cx="438912" cy="438912"/>
+            <a:off x="2907792" y="3262057"/>
+            <a:ext cx="438912" cy="388750"/>
           </a:xfrm>
           <a:prstGeom prst="rect">
             <a:avLst/>
@@ -7548,8 +7548,8 @@
         </p:blipFill>
         <p:spPr>
           <a:xfrm>
-            <a:off x="3456432" y="4261104"/>
-            <a:ext cx="438912" cy="438912"/>
+            <a:off x="3456432" y="4429855"/>
+            <a:ext cx="438912" cy="101409"/>
           </a:xfrm>
           <a:prstGeom prst="rect">
             <a:avLst/>
@@ -7643,8 +7643,8 @@
         </p:blipFill>
         <p:spPr>
           <a:xfrm>
-            <a:off x="6199632" y="2176272"/>
-            <a:ext cx="749808" cy="658368"/>
+            <a:off x="6245352" y="2176272"/>
+            <a:ext cx="658368" cy="658368"/>
           </a:xfrm>
           <a:prstGeom prst="rect">
             <a:avLst/>
@@ -7748,8 +7748,8 @@
         </p:blipFill>
         <p:spPr>
           <a:xfrm>
-            <a:off x="6995160" y="2176272"/>
-            <a:ext cx="749808" cy="658368"/>
+            <a:off x="6995160" y="2194332"/>
+            <a:ext cx="749808" cy="622247"/>
           </a:xfrm>
           <a:prstGeom prst="rect">
             <a:avLst/>
@@ -7853,8 +7853,8 @@
         </p:blipFill>
         <p:spPr>
           <a:xfrm>
-            <a:off x="7790688" y="2176272"/>
-            <a:ext cx="749808" cy="658368"/>
+            <a:off x="7790688" y="2269237"/>
+            <a:ext cx="749808" cy="472437"/>
           </a:xfrm>
           <a:prstGeom prst="rect">
             <a:avLst/>
@@ -7958,8 +7958,8 @@
         </p:blipFill>
         <p:spPr>
           <a:xfrm>
-            <a:off x="8586215" y="2176272"/>
-            <a:ext cx="749808" cy="658368"/>
+            <a:off x="8631935" y="2176272"/>
+            <a:ext cx="658368" cy="658368"/>
           </a:xfrm>
           <a:prstGeom prst="rect">
             <a:avLst/>
@@ -8063,8 +8063,8 @@
         </p:blipFill>
         <p:spPr>
           <a:xfrm>
-            <a:off x="9381743" y="2176272"/>
-            <a:ext cx="749808" cy="658368"/>
+            <a:off x="9381743" y="2251377"/>
+            <a:ext cx="749808" cy="508157"/>
           </a:xfrm>
           <a:prstGeom prst="rect">
             <a:avLst/>
@@ -8168,8 +8168,8 @@
         </p:blipFill>
         <p:spPr>
           <a:xfrm>
-            <a:off x="10177271" y="2176272"/>
-            <a:ext cx="749808" cy="658368"/>
+            <a:off x="10222991" y="2176272"/>
+            <a:ext cx="658368" cy="658368"/>
           </a:xfrm>
           <a:prstGeom prst="rect">
             <a:avLst/>
@@ -8273,8 +8273,8 @@
         </p:blipFill>
         <p:spPr>
           <a:xfrm>
-            <a:off x="10972799" y="2176272"/>
-            <a:ext cx="749808" cy="658368"/>
+            <a:off x="10972799" y="2354216"/>
+            <a:ext cx="749808" cy="302479"/>
           </a:xfrm>
           <a:prstGeom prst="rect">
             <a:avLst/>
@@ -8779,8 +8779,8 @@
         </p:blipFill>
         <p:spPr>
           <a:xfrm>
-            <a:off x="886968" y="2084831"/>
-            <a:ext cx="2670048" cy="1051560"/>
+            <a:off x="918650" y="2084831"/>
+            <a:ext cx="2606683" cy="1051560"/>
           </a:xfrm>
           <a:prstGeom prst="rect">
             <a:avLst/>
@@ -8965,8 +8965,8 @@
         </p:blipFill>
         <p:spPr>
           <a:xfrm>
-            <a:off x="4270248" y="2084831"/>
-            <a:ext cx="2670048" cy="1051560"/>
+            <a:off x="4270248" y="2302158"/>
+            <a:ext cx="2670048" cy="616906"/>
           </a:xfrm>
           <a:prstGeom prst="rect">
             <a:avLst/>
@@ -9151,8 +9151,8 @@
         </p:blipFill>
         <p:spPr>
           <a:xfrm>
-            <a:off x="7653527" y="2084831"/>
-            <a:ext cx="2670048" cy="1051560"/>
+            <a:off x="8154083" y="2084831"/>
+            <a:ext cx="1668935" cy="1051560"/>
           </a:xfrm>
           <a:prstGeom prst="rect">
             <a:avLst/>
@@ -9543,8 +9543,8 @@
         </p:blipFill>
         <p:spPr>
           <a:xfrm>
-            <a:off x="886968" y="2057400"/>
-            <a:ext cx="2670048" cy="1188720"/>
+            <a:off x="1627632" y="2057400"/>
+            <a:ext cx="1188720" cy="1188720"/>
           </a:xfrm>
           <a:prstGeom prst="rect">
             <a:avLst/>
@@ -9729,8 +9729,8 @@
         </p:blipFill>
         <p:spPr>
           <a:xfrm>
-            <a:off x="4315968" y="2057400"/>
-            <a:ext cx="2670048" cy="1188720"/>
+            <a:off x="5056632" y="2057400"/>
+            <a:ext cx="1188720" cy="1188720"/>
           </a:xfrm>
           <a:prstGeom prst="rect">
             <a:avLst/>
@@ -9915,8 +9915,8 @@
         </p:blipFill>
         <p:spPr>
           <a:xfrm>
-            <a:off x="7744968" y="2057400"/>
-            <a:ext cx="2670048" cy="1188720"/>
+            <a:off x="8021602" y="2057400"/>
+            <a:ext cx="2116780" cy="1188720"/>
           </a:xfrm>
           <a:prstGeom prst="rect">
             <a:avLst/>
@@ -10387,8 +10387,8 @@
         </p:blipFill>
         <p:spPr>
           <a:xfrm>
-            <a:off x="932688" y="2057400"/>
-            <a:ext cx="2697480" cy="1078992"/>
+            <a:off x="944086" y="2057400"/>
+            <a:ext cx="2674684" cy="1078992"/>
           </a:xfrm>
           <a:prstGeom prst="rect">
             <a:avLst/>
@@ -10574,8 +10574,8 @@
         </p:blipFill>
         <p:spPr>
           <a:xfrm>
-            <a:off x="4553712" y="2057400"/>
-            <a:ext cx="2450592" cy="1078992"/>
+            <a:off x="5169900" y="2057400"/>
+            <a:ext cx="1218216" cy="1078992"/>
           </a:xfrm>
           <a:prstGeom prst="rect">
             <a:avLst/>
@@ -11211,8 +11211,8 @@
         </p:blipFill>
         <p:spPr>
           <a:xfrm>
-            <a:off x="914400" y="2057400"/>
-            <a:ext cx="2816352" cy="1188720"/>
+            <a:off x="1379264" y="2057400"/>
+            <a:ext cx="1886623" cy="1188720"/>
           </a:xfrm>
           <a:prstGeom prst="rect">
             <a:avLst/>
@@ -11398,8 +11398,8 @@
         </p:blipFill>
         <p:spPr>
           <a:xfrm>
-            <a:off x="4480560" y="2057400"/>
-            <a:ext cx="2788920" cy="1188720"/>
+            <a:off x="5280660" y="2057400"/>
+            <a:ext cx="1188720" cy="1188720"/>
           </a:xfrm>
           <a:prstGeom prst="rect">
             <a:avLst/>
@@ -12033,8 +12033,8 @@
         </p:blipFill>
         <p:spPr>
           <a:xfrm>
-            <a:off x="914400" y="2084831"/>
-            <a:ext cx="2633472" cy="1325880"/>
+            <a:off x="1568196" y="2084831"/>
+            <a:ext cx="1325880" cy="1325880"/>
           </a:xfrm>
           <a:prstGeom prst="rect">
             <a:avLst/>
@@ -12219,8 +12219,8 @@
         </p:blipFill>
         <p:spPr>
           <a:xfrm>
-            <a:off x="4315968" y="2194560"/>
-            <a:ext cx="2633472" cy="777240"/>
+            <a:off x="4315968" y="2278952"/>
+            <a:ext cx="2633472" cy="608455"/>
           </a:xfrm>
           <a:prstGeom prst="rect">
             <a:avLst/>
@@ -12888,8 +12888,8 @@
         </p:blipFill>
         <p:spPr>
           <a:xfrm>
-            <a:off x="932688" y="2057400"/>
-            <a:ext cx="2057400" cy="1143000"/>
+            <a:off x="943705" y="2057400"/>
+            <a:ext cx="2035366" cy="1143000"/>
           </a:xfrm>
           <a:prstGeom prst="rect">
             <a:avLst/>
@@ -13109,8 +13109,8 @@
         </p:blipFill>
         <p:spPr>
           <a:xfrm>
-            <a:off x="6291072" y="2057400"/>
-            <a:ext cx="2057400" cy="1143000"/>
+            <a:off x="6748272" y="2057400"/>
+            <a:ext cx="1143000" cy="1143000"/>
           </a:xfrm>
           <a:prstGeom prst="rect">
             <a:avLst/>

</xml_diff>